<commit_message>
homa-lab 0.3.0: segmentation offload findings, hijack GRO patch, suite 08
Co-Authored-By: Claude Opus 5.5 <noreply@anthropic.com>
Claude-Session: https://claude.ai/code/session_01PdFLLzZwvHtz4kVKpJFsWu
</commit_message>
<xml_diff>
--- a/docs/homa-lab.pptx
+++ b/docs/homa-lab.pptx
@@ -1797,7 +1797,7 @@
           <a:lstStyle/>
           <a:p>
             <a:r>
-              <a:t>Light mixed load: Homa's W3 message-size distribution at 0.3 Gbit/s, about 170,000 RPCs each. Medians are close (short: Homa 0.29 ms, TCP 0.32 ms). Homa's p99 is lower for short and medium messages; TCP wins long messages because the virtio NICs give it segmentation offload and Homa gets none.</a:t>
+              <a:t>Light mixed load: Homa's W3 message-size distribution at 0.3 Gbit/s, about 170,000 RPCs each. Medians are close (short: Homa 0.29 ms, TCP 0.32 ms). Homa's p99 is lower for short and medium messages; TCP wins long messages. Not because of offload: with offload working for Homa (patched module) its long-message median stayed the same. The cause is open.</a:t>
             </a:r>
           </a:p>
         </p:txBody>
@@ -2077,7 +2077,7 @@
           <a:lstStyle/>
           <a:p>
             <a:r>
-              <a:t>./lab.sh test runs seven Robot suites in about 12 minutes; the last full run passed all 26 tests. Suite 07 keeps the timer finding as a regression test.</a:t>
+              <a:t>./lab.sh test runs eight Robot suites in about 5 minutes; the last full run passed all 30 tests. Suite 07 keeps the timer finding as a regression test, suite 08 the offload findings, including the module bug.</a:t>
             </a:r>
           </a:p>
         </p:txBody>
@@ -2217,7 +2217,7 @@
           <a:lstStyle/>
           <a:p>
             <a:r>
-              <a:t>Not built yet: portal and NMS integration, the upstream patch-series kernel as a second track, the offload investigation, and HomaModule's cluster benchmarks adapted to four nodes.</a:t>
+              <a:t>Not built yet: the upstream patch-series kernel as a second track, reporting the hijack bug, the long-message gap, and HomaModule's cluster benchmarks adapted to four nodes.</a:t>
             </a:r>
           </a:p>
         </p:txBody>
@@ -2637,7 +2637,7 @@
           <a:lstStyle/>
           <a:p>
             <a:r>
-              <a:t>Drawbacks, several measured in this lab: without priority queues the short-message advantage shrinks about 10x at the median; TCP wins big transfers because NIC offloads only understand TCP; the default timers misfire at 1 Gbit/s. grant_fifo_fraction reserves bandwidth for the oldest message and is 0 (off) in this build.</a:t>
+              <a:t>Drawbacks, several measured in this lab: without priority queues the short-message advantage shrinks about 10x at the median; TCP wins big transfers here (not because of offload: the gap stayed with offload working for Homa); the default timers misfire at 1 Gbit/s. grant_fifo_fraction reserves bandwidth for the oldest message and is 0 (off) in this build.</a:t>
             </a:r>
           </a:p>
         </p:txBody>
@@ -5878,7 +5878,7 @@
                 </a:solidFill>
                 <a:latin typeface="Calibri"/>
               </a:rPr>
-              <a:t>homa-lab 0.1.1  ·  kernel 6.17.8  ·  HomaModule main @ 65cecd7  ·  26 of 26 tests passing</a:t>
+              <a:t>homa-lab 0.3.0  ·  kernel 6.17.8  ·  HomaModule main @ 65cecd7  ·  30 of 30 tests passing</a:t>
             </a:r>
           </a:p>
           <a:p>
@@ -10527,7 +10527,7 @@
                 </a:solidFill>
                 <a:latin typeface="Calibri"/>
               </a:rPr>
-              <a:t>Long messages: TCP 15.9 ms, Homa 20.9 ms — TCP has NIC offload, Homa doesn't.</a:t>
+              <a:t>Long messages: TCP 15.9 ms, Homa 20.9 ms. Not offload: the gap stayed with it working for Homa.</a:t>
             </a:r>
           </a:p>
         </p:txBody>
@@ -13126,7 +13126,7 @@
                 </a:solidFill>
                 <a:latin typeface="Calibri"/>
               </a:rPr>
-              <a:t>26 tests</a:t>
+              <a:t>30 tests</a:t>
             </a:r>
           </a:p>
         </p:txBody>
@@ -13168,7 +13168,7 @@
                 </a:solidFill>
                 <a:latin typeface="Calibri"/>
               </a:rPr>
-              <a:t>Robot suites: platform, function v4/v6, the wire, Homa vs TCP, incast, loss recovery, resend timers.</a:t>
+              <a:t>Robot suites: platform, function v4/v6, the wire, Homa vs TCP, incast, loss recovery, timers, offload.</a:t>
             </a:r>
           </a:p>
         </p:txBody>
@@ -13272,7 +13272,7 @@
                 </a:solidFill>
                 <a:latin typeface="Cambria"/>
               </a:rPr>
-              <a:t>26 tests, seven suites</a:t>
+              <a:t>30 tests, eight suites</a:t>
             </a:r>
           </a:p>
         </p:txBody>
@@ -13314,7 +13314,7 @@
                 </a:solidFill>
                 <a:latin typeface="Calibri"/>
               </a:rPr>
-              <a:t>./lab.sh test — about 12 minutes; the last full run passed 26 of 26</a:t>
+              <a:t>./lab.sh test — about 5 minutes; the last full run passed 30 of 30</a:t>
             </a:r>
           </a:p>
         </p:txBody>
@@ -13329,7 +13329,7 @@
         </p:nvGraphicFramePr>
         <p:xfrm>
           <a:off x="685800" y="1783080"/>
-          <a:ext cx="10817350" cy="4389120"/>
+          <a:ext cx="10817350" cy="4526280"/>
         </p:xfrm>
         <a:graphic>
           <a:graphicData uri="http://schemas.openxmlformats.org/drawingml/2006/table">
@@ -13342,7 +13342,7 @@
                 <a:gridCol w="7991196"/>
                 <a:gridCol w="974536"/>
               </a:tblGrid>
-              <a:tr h="548640">
+              <a:tr h="502920">
                 <a:tc>
                   <a:txBody>
                     <a:bodyPr/>
@@ -13410,7 +13410,7 @@
                   </a:tcPr>
                 </a:tc>
               </a:tr>
-              <a:tr h="548640">
+              <a:tr h="502920">
                 <a:tc>
                   <a:txBody>
                     <a:bodyPr/>
@@ -13478,7 +13478,7 @@
                   </a:tcPr>
                 </a:tc>
               </a:tr>
-              <a:tr h="548640">
+              <a:tr h="502920">
                 <a:tc>
                   <a:txBody>
                     <a:bodyPr/>
@@ -13546,7 +13546,7 @@
                   </a:tcPr>
                 </a:tc>
               </a:tr>
-              <a:tr h="548640">
+              <a:tr h="502920">
                 <a:tc>
                   <a:txBody>
                     <a:bodyPr/>
@@ -13614,7 +13614,7 @@
                   </a:tcPr>
                 </a:tc>
               </a:tr>
-              <a:tr h="548640">
+              <a:tr h="502920">
                 <a:tc>
                   <a:txBody>
                     <a:bodyPr/>
@@ -13682,7 +13682,7 @@
                   </a:tcPr>
                 </a:tc>
               </a:tr>
-              <a:tr h="548640">
+              <a:tr h="502920">
                 <a:tc>
                   <a:txBody>
                     <a:bodyPr/>
@@ -13750,7 +13750,7 @@
                   </a:tcPr>
                 </a:tc>
               </a:tr>
-              <a:tr h="548640">
+              <a:tr h="502920">
                 <a:tc>
                   <a:txBody>
                     <a:bodyPr/>
@@ -13818,7 +13818,7 @@
                   </a:tcPr>
                 </a:tc>
               </a:tr>
-              <a:tr h="548640">
+              <a:tr h="502920">
                 <a:tc>
                   <a:txBody>
                     <a:bodyPr/>
@@ -13886,6 +13886,74 @@
                   </a:tcPr>
                 </a:tc>
               </a:tr>
+              <a:tr h="502920">
+                <a:tc>
+                  <a:txBody>
+                    <a:bodyPr/>
+                    <a:lstStyle/>
+                    <a:p>
+                      <a:r>
+                        <a:rPr sz="1500" b="1">
+                          <a:solidFill>
+                            <a:srgbClr val="1F2937"/>
+                          </a:solidFill>
+                          <a:latin typeface="Calibri"/>
+                        </a:rPr>
+                        <a:t>08 offload</a:t>
+                      </a:r>
+                    </a:p>
+                  </a:txBody>
+                  <a:tcPr marL="91440" marR="91440" marT="36576" marB="36576" anchor="ctr">
+                    <a:solidFill>
+                      <a:srgbClr val="EEF2F7"/>
+                    </a:solidFill>
+                  </a:tcPr>
+                </a:tc>
+                <a:tc>
+                  <a:txBody>
+                    <a:bodyPr/>
+                    <a:lstStyle/>
+                    <a:p>
+                      <a:r>
+                        <a:rPr sz="1500" b="0">
+                          <a:solidFill>
+                            <a:srgbClr val="1F2937"/>
+                          </a:solidFill>
+                          <a:latin typeface="Calibri"/>
+                        </a:rPr>
+                        <a:t>GSO lost on the host with TSO on, works when the guest segments; the hijack bug</a:t>
+                      </a:r>
+                    </a:p>
+                  </a:txBody>
+                  <a:tcPr marL="91440" marR="91440" marT="36576" marB="36576" anchor="ctr">
+                    <a:solidFill>
+                      <a:srgbClr val="EEF2F7"/>
+                    </a:solidFill>
+                  </a:tcPr>
+                </a:tc>
+                <a:tc>
+                  <a:txBody>
+                    <a:bodyPr/>
+                    <a:lstStyle/>
+                    <a:p>
+                      <a:r>
+                        <a:rPr sz="1500" b="0">
+                          <a:solidFill>
+                            <a:srgbClr val="1F2937"/>
+                          </a:solidFill>
+                          <a:latin typeface="Calibri"/>
+                        </a:rPr>
+                        <a:t>4</a:t>
+                      </a:r>
+                    </a:p>
+                  </a:txBody>
+                  <a:tcPr marL="91440" marR="91440" marT="36576" marB="36576" anchor="ctr">
+                    <a:solidFill>
+                      <a:srgbClr val="EEF2F7"/>
+                    </a:solidFill>
+                  </a:tcPr>
+                </a:tc>
+              </a:tr>
             </a:tbl>
           </a:graphicData>
         </a:graphic>
@@ -14343,7 +14411,7 @@
                 </a:solidFill>
                 <a:latin typeface="Calibri"/>
               </a:rPr>
-              <a:t>Offload gap</a:t>
+              <a:t>Offload, two causes</a:t>
             </a:r>
           </a:p>
         </p:txBody>
@@ -14385,7 +14453,7 @@
                 </a:solidFill>
                 <a:latin typeface="Calibri"/>
               </a:rPr>
-              <a:t>NICs segment TCP, not Homa; its GSO and TCP-hijack modes failed for 1 MB messages here.</a:t>
+              <a:t>GSO frames die on the lab host (no Homa there); TCP hijacking hit a module bug, patched.</a:t>
             </a:r>
           </a:p>
         </p:txBody>
@@ -14797,7 +14865,7 @@
                 </a:solidFill>
                 <a:latin typeface="Calibri"/>
               </a:rPr>
-              <a:t>Portal and metrics</a:t>
+              <a:t>Report the bug</a:t>
             </a:r>
           </a:p>
         </p:txBody>
@@ -14839,7 +14907,7 @@
                 </a:solidFill>
                 <a:latin typeface="Calibri"/>
               </a:rPr>
-              <a:t>A Prometheus exporter for Homa's metrics, a Grafana board, a portal on port 8108.</a:t>
+              <a:t>The TCP-hijack fix and a bug report draft are in patches/, ready for HomaModule upstream.</a:t>
             </a:r>
           </a:p>
         </p:txBody>
@@ -15233,7 +15301,7 @@
                 </a:solidFill>
                 <a:latin typeface="Calibri"/>
               </a:rPr>
-              <a:t>Offloads</a:t>
+              <a:t>Long messages</a:t>
             </a:r>
           </a:p>
         </p:txBody>
@@ -15275,7 +15343,7 @@
                 </a:solidFill>
                 <a:latin typeface="Calibri"/>
               </a:rPr>
-              <a:t>Why GSO'd and TCP-hijacked large messages time out here.</a:t>
+              <a:t>Why TCP still beats Homa on long messages here, with offload working for both.</a:t>
             </a:r>
           </a:p>
         </p:txBody>
@@ -19310,7 +19378,7 @@
                 </a:solidFill>
                 <a:latin typeface="Calibri"/>
               </a:rPr>
-              <a:t>Offloads are for TCP</a:t>
+              <a:t>Offload is fragile</a:t>
             </a:r>
           </a:p>
         </p:txBody>
@@ -19352,7 +19420,7 @@
                 </a:solidFill>
                 <a:latin typeface="Calibri"/>
               </a:rPr>
-              <a:t>NICs don't segment Homa; TCP was faster for big transfers here.</a:t>
+              <a:t>Hardware TSO is TCP-only. Homa's GSO hit a host limit here, its TCP disguise a module bug.</a:t>
             </a:r>
           </a:p>
         </p:txBody>
@@ -20387,7 +20455,7 @@
                           </a:solidFill>
                           <a:latin typeface="Calibri"/>
                         </a:rPr>
-                        <a:t>no offload; can be starved</a:t>
+                        <a:t>offload only by workarounds; can be starved</a:t>
                       </a:r>
                     </a:p>
                   </a:txBody>

</xml_diff>